<commit_message>
Adapt Cramer-Rao presentation to native Bento format
</commit_message>
<xml_diff>
--- a/cramer-rao-bound/Cramer-Rao-Bound.pptx
+++ b/cramer-rao-bound/Cramer-Rao-Bound.pptx
@@ -831,7 +831,7 @@
           <a:p/>
           <a:p>
             <a:r>
-              <a:t>LIVE LAB: Open Cramer-Rao-Bound.html in a browser, then choose this lab from Overview. This PowerPoint is a static snapshot; the controls in the image do not respond.</a:t>
+              <a:t>LIVE LAB: Open Cramer-Rao-Bound.html in a browser and choose TRY LIVE on this slide. This PowerPoint is a static snapshot.</a:t>
             </a:r>
           </a:p>
           <a:p/>
@@ -1317,7 +1317,7 @@
           <a:p/>
           <a:p>
             <a:r>
-              <a:t>LIVE LAB: Open Cramer-Rao-Bound.html in a browser, then choose this lab from Overview. This PowerPoint is a static snapshot; the controls in the image do not respond.</a:t>
+              <a:t>LIVE LAB: Open Cramer-Rao-Bound.html in a browser and choose TRY LIVE on this slide. This PowerPoint is a static snapshot.</a:t>
             </a:r>
           </a:p>
           <a:p/>
@@ -2003,7 +2003,7 @@
           <a:p/>
           <a:p>
             <a:r>
-              <a:t>Source mapping: S1 grounds the scalar proof, Gaussian calculation, and efficiency discussion. S2 gives broad information and estimation context. S3 grounds localization-information geometry and equivalent Fisher information; this deck’s independent Gaussian-range toy model is deliberately simpler than that paper’s waveform-level model. S4 supports the carefully qualified asymptotic MLE statement. The biased extension, uniform-maximum calculation, linear Gaussian design consequences, figures, and numerical demos are independently derived teaching examples. Links navigate in the same tab, following the site convention. The existing site’s warm paper, Georgia headings, and restrained teal/blue/rust palette informed the visual design.</a:t>
+              <a:t>Source mapping: S1 grounds the scalar proof, Gaussian calculation, and efficiency discussion. S2 gives broad information and estimation context. S3 grounds localization-information geometry and equivalent Fisher information; this deck’s independent Gaussian-range toy model is deliberately simpler than that paper’s waveform-level model. S4 supports the carefully qualified asymptotic MLE statement. The biased extension, uniform-maximum calculation, linear Gaussian design consequences, figures, and numerical demos are independently derived teaching examples. Links navigate in the same tab, following the site convention. The deck uses the site’s technical Bento presentation format; full explanations and compact labs are linked in the same tab.</a:t>
             </a:r>
           </a:p>
           <a:p/>
@@ -2685,7 +2685,7 @@
           <a:p/>
           <a:p>
             <a:r>
-              <a:t>LIVE LAB: Open Cramer-Rao-Bound.html in a browser, then choose this lab from Overview. This PowerPoint is a static snapshot; the controls in the image do not respond.</a:t>
+              <a:t>LIVE LAB: Open Cramer-Rao-Bound.html in a browser and choose TRY LIVE on this slide. This PowerPoint is a static snapshot.</a:t>
             </a:r>
           </a:p>
           <a:p/>

</xml_diff>

<commit_message>
Show Cramer-Rao experiments directly inside slides
</commit_message>
<xml_diff>
--- a/cramer-rao-bound/Cramer-Rao-Bound.pptx
+++ b/cramer-rao-bound/Cramer-Rao-Bound.pptx
@@ -831,7 +831,7 @@
           <a:p/>
           <a:p>
             <a:r>
-              <a:t>LIVE LAB: Open Cramer-Rao-Bound.html in a browser and choose TRY LIVE on this slide. This PowerPoint is a static snapshot.</a:t>
+              <a:t>LIVE LAB: Open Cramer-Rao-Bound.html in a browser. The interactive controls load directly on this slide. This PowerPoint is a static snapshot.</a:t>
             </a:r>
           </a:p>
           <a:p/>
@@ -1317,7 +1317,7 @@
           <a:p/>
           <a:p>
             <a:r>
-              <a:t>LIVE LAB: Open Cramer-Rao-Bound.html in a browser and choose TRY LIVE on this slide. This PowerPoint is a static snapshot.</a:t>
+              <a:t>LIVE LAB: Open Cramer-Rao-Bound.html in a browser. The interactive controls load directly on this slide. This PowerPoint is a static snapshot.</a:t>
             </a:r>
           </a:p>
           <a:p/>
@@ -2685,7 +2685,7 @@
           <a:p/>
           <a:p>
             <a:r>
-              <a:t>LIVE LAB: Open Cramer-Rao-Bound.html in a browser and choose TRY LIVE on this slide. This PowerPoint is a static snapshot.</a:t>
+              <a:t>LIVE LAB: Open Cramer-Rao-Bound.html in a browser. The interactive controls load directly on this slide. This PowerPoint is a static snapshot.</a:t>
             </a:r>
           </a:p>
           <a:p/>

</xml_diff>